<commit_message>
Zle odrátavanie kariet po kole v turnajovom móde
</commit_message>
<xml_diff>
--- a/RPJ/Grafická_aplikácia_sieťovej_hry-Šrobár_Šimon-4SC.pptx
+++ b/RPJ/Grafická_aplikácia_sieťovej_hry-Šrobár_Šimon-4SC.pptx
@@ -18,9 +18,10 @@
     <p:sldId id="274" r:id="rId12"/>
     <p:sldId id="275" r:id="rId13"/>
     <p:sldId id="278" r:id="rId14"/>
-    <p:sldId id="265" r:id="rId15"/>
-    <p:sldId id="276" r:id="rId16"/>
-    <p:sldId id="266" r:id="rId17"/>
+    <p:sldId id="279" r:id="rId15"/>
+    <p:sldId id="265" r:id="rId16"/>
+    <p:sldId id="276" r:id="rId17"/>
+    <p:sldId id="266" r:id="rId18"/>
   </p:sldIdLst>
   <p:sldSz cx="12192000" cy="6858000"/>
   <p:notesSz cx="6858000" cy="9144000"/>
@@ -286,7 +287,7 @@
           <a:p>
             <a:fld id="{4F57F2D5-49DA-4868-8E86-9C375FBA7C31}" type="datetimeFigureOut">
               <a:rPr lang="sk-SK" smtClean="0"/>
-              <a:t>6. 5. 2026</a:t>
+              <a:t>10. 5. 2026</a:t>
             </a:fld>
             <a:endParaRPr lang="sk-SK"/>
           </a:p>
@@ -484,7 +485,7 @@
           <a:p>
             <a:fld id="{4F57F2D5-49DA-4868-8E86-9C375FBA7C31}" type="datetimeFigureOut">
               <a:rPr lang="sk-SK" smtClean="0"/>
-              <a:t>6. 5. 2026</a:t>
+              <a:t>10. 5. 2026</a:t>
             </a:fld>
             <a:endParaRPr lang="sk-SK"/>
           </a:p>
@@ -692,7 +693,7 @@
           <a:p>
             <a:fld id="{4F57F2D5-49DA-4868-8E86-9C375FBA7C31}" type="datetimeFigureOut">
               <a:rPr lang="sk-SK" smtClean="0"/>
-              <a:t>6. 5. 2026</a:t>
+              <a:t>10. 5. 2026</a:t>
             </a:fld>
             <a:endParaRPr lang="sk-SK"/>
           </a:p>
@@ -890,7 +891,7 @@
           <a:p>
             <a:fld id="{4F57F2D5-49DA-4868-8E86-9C375FBA7C31}" type="datetimeFigureOut">
               <a:rPr lang="sk-SK" smtClean="0"/>
-              <a:t>6. 5. 2026</a:t>
+              <a:t>10. 5. 2026</a:t>
             </a:fld>
             <a:endParaRPr lang="sk-SK"/>
           </a:p>
@@ -1165,7 +1166,7 @@
           <a:p>
             <a:fld id="{4F57F2D5-49DA-4868-8E86-9C375FBA7C31}" type="datetimeFigureOut">
               <a:rPr lang="sk-SK" smtClean="0"/>
-              <a:t>6. 5. 2026</a:t>
+              <a:t>10. 5. 2026</a:t>
             </a:fld>
             <a:endParaRPr lang="sk-SK"/>
           </a:p>
@@ -1430,7 +1431,7 @@
           <a:p>
             <a:fld id="{4F57F2D5-49DA-4868-8E86-9C375FBA7C31}" type="datetimeFigureOut">
               <a:rPr lang="sk-SK" smtClean="0"/>
-              <a:t>6. 5. 2026</a:t>
+              <a:t>10. 5. 2026</a:t>
             </a:fld>
             <a:endParaRPr lang="sk-SK"/>
           </a:p>
@@ -1842,7 +1843,7 @@
           <a:p>
             <a:fld id="{4F57F2D5-49DA-4868-8E86-9C375FBA7C31}" type="datetimeFigureOut">
               <a:rPr lang="sk-SK" smtClean="0"/>
-              <a:t>6. 5. 2026</a:t>
+              <a:t>10. 5. 2026</a:t>
             </a:fld>
             <a:endParaRPr lang="sk-SK"/>
           </a:p>
@@ -1983,7 +1984,7 @@
           <a:p>
             <a:fld id="{4F57F2D5-49DA-4868-8E86-9C375FBA7C31}" type="datetimeFigureOut">
               <a:rPr lang="sk-SK" smtClean="0"/>
-              <a:t>6. 5. 2026</a:t>
+              <a:t>10. 5. 2026</a:t>
             </a:fld>
             <a:endParaRPr lang="sk-SK"/>
           </a:p>
@@ -2096,7 +2097,7 @@
           <a:p>
             <a:fld id="{4F57F2D5-49DA-4868-8E86-9C375FBA7C31}" type="datetimeFigureOut">
               <a:rPr lang="sk-SK" smtClean="0"/>
-              <a:t>6. 5. 2026</a:t>
+              <a:t>10. 5. 2026</a:t>
             </a:fld>
             <a:endParaRPr lang="sk-SK"/>
           </a:p>
@@ -2407,7 +2408,7 @@
           <a:p>
             <a:fld id="{4F57F2D5-49DA-4868-8E86-9C375FBA7C31}" type="datetimeFigureOut">
               <a:rPr lang="sk-SK" smtClean="0"/>
-              <a:t>6. 5. 2026</a:t>
+              <a:t>10. 5. 2026</a:t>
             </a:fld>
             <a:endParaRPr lang="sk-SK"/>
           </a:p>
@@ -2695,7 +2696,7 @@
           <a:p>
             <a:fld id="{4F57F2D5-49DA-4868-8E86-9C375FBA7C31}" type="datetimeFigureOut">
               <a:rPr lang="sk-SK" smtClean="0"/>
-              <a:t>6. 5. 2026</a:t>
+              <a:t>10. 5. 2026</a:t>
             </a:fld>
             <a:endParaRPr lang="sk-SK"/>
           </a:p>
@@ -2936,7 +2937,7 @@
           <a:p>
             <a:fld id="{4F57F2D5-49DA-4868-8E86-9C375FBA7C31}" type="datetimeFigureOut">
               <a:rPr lang="sk-SK" smtClean="0"/>
-              <a:t>6. 5. 2026</a:t>
+              <a:t>10. 5. 2026</a:t>
             </a:fld>
             <a:endParaRPr lang="sk-SK"/>
           </a:p>
@@ -3916,43 +3917,130 @@
       </p:grpSpPr>
       <p:sp>
         <p:nvSpPr>
-          <p:cNvPr id="6" name="BlokTextu 5">
-            <a:extLst>
-              <a:ext uri="{FF2B5EF4-FFF2-40B4-BE49-F238E27FC236}">
-                <a16:creationId xmlns:a16="http://schemas.microsoft.com/office/drawing/2014/main" id="{08597A8F-7FB2-4750-B896-0FAD63F62091}"/>
-              </a:ext>
-            </a:extLst>
-          </p:cNvPr>
-          <p:cNvSpPr txBox="1"/>
-          <p:nvPr/>
+          <p:cNvPr id="2" name="Title 1">
+            <a:extLst>
+              <a:ext uri="{FF2B5EF4-FFF2-40B4-BE49-F238E27FC236}">
+                <a16:creationId xmlns:a16="http://schemas.microsoft.com/office/drawing/2014/main" id="{C6986458-6037-628E-29E8-2AA707C17341}"/>
+              </a:ext>
+            </a:extLst>
+          </p:cNvPr>
+          <p:cNvSpPr>
+            <a:spLocks noGrp="1"/>
+          </p:cNvSpPr>
+          <p:nvPr>
+            <p:ph type="title"/>
+          </p:nvPr>
+        </p:nvSpPr>
+        <p:spPr/>
+        <p:txBody>
+          <a:bodyPr/>
+          <a:lstStyle/>
+          <a:p>
+            <a:r>
+              <a:rPr lang="sk-SK" noProof="0" dirty="0"/>
+              <a:t>Stiahnutie hry</a:t>
+            </a:r>
+          </a:p>
+        </p:txBody>
+      </p:sp>
+      <p:sp>
+        <p:nvSpPr>
+          <p:cNvPr id="3" name="Content Placeholder 2">
+            <a:extLst>
+              <a:ext uri="{FF2B5EF4-FFF2-40B4-BE49-F238E27FC236}">
+                <a16:creationId xmlns:a16="http://schemas.microsoft.com/office/drawing/2014/main" id="{D136FB51-3ABE-98DA-B755-D09BD1E7BB84}"/>
+              </a:ext>
+            </a:extLst>
+          </p:cNvPr>
+          <p:cNvSpPr>
+            <a:spLocks noGrp="1"/>
+          </p:cNvSpPr>
+          <p:nvPr>
+            <p:ph idx="1"/>
+          </p:nvPr>
         </p:nvSpPr>
         <p:spPr>
           <a:xfrm>
-            <a:off x="639288" y="2921168"/>
-            <a:ext cx="10913423" cy="1015663"/>
+            <a:off x="286139" y="2141537"/>
+            <a:ext cx="10515600" cy="4351338"/>
+          </a:xfrm>
+        </p:spPr>
+        <p:txBody>
+          <a:bodyPr>
+            <a:normAutofit/>
+          </a:bodyPr>
+          <a:lstStyle/>
+          <a:p>
+            <a:r>
+              <a:rPr lang="en-GB" noProof="0" dirty="0"/>
+              <a:t>Inno Setup Compiler (</a:t>
+            </a:r>
+            <a:r>
+              <a:rPr lang="en-GB" noProof="0" dirty="0" err="1"/>
+              <a:t>inštalačka</a:t>
+            </a:r>
+            <a:r>
+              <a:rPr lang="en-GB" noProof="0" dirty="0"/>
+              <a:t>)</a:t>
+            </a:r>
+          </a:p>
+          <a:p>
+            <a:r>
+              <a:rPr lang="en-GB" dirty="0"/>
+              <a:t>Itch.io (</a:t>
+            </a:r>
+            <a:r>
+              <a:rPr lang="en-GB" dirty="0" err="1"/>
+              <a:t>zadarmo</a:t>
+            </a:r>
+            <a:r>
+              <a:rPr lang="en-GB" dirty="0"/>
+              <a:t>)</a:t>
+            </a:r>
+          </a:p>
+          <a:p>
+            <a:r>
+              <a:rPr lang="en-GB" noProof="0"/>
+              <a:t>GitHub (Open source)</a:t>
+            </a:r>
+            <a:endParaRPr lang="sk-SK" noProof="0" dirty="0"/>
+          </a:p>
+        </p:txBody>
+      </p:sp>
+      <p:pic>
+        <p:nvPicPr>
+          <p:cNvPr id="7" name="Picture 6">
+            <a:extLst>
+              <a:ext uri="{FF2B5EF4-FFF2-40B4-BE49-F238E27FC236}">
+                <a16:creationId xmlns:a16="http://schemas.microsoft.com/office/drawing/2014/main" id="{274FE96D-FF99-14BF-6A76-AE043420793F}"/>
+              </a:ext>
+            </a:extLst>
+          </p:cNvPr>
+          <p:cNvPicPr>
+            <a:picLocks noChangeAspect="1"/>
+          </p:cNvPicPr>
+          <p:nvPr/>
+        </p:nvPicPr>
+        <p:blipFill>
+          <a:blip r:embed="rId2"/>
+          <a:stretch>
+            <a:fillRect/>
+          </a:stretch>
+        </p:blipFill>
+        <p:spPr>
+          <a:xfrm>
+            <a:off x="5957762" y="1901094"/>
+            <a:ext cx="5948099" cy="4591781"/>
           </a:xfrm>
           <a:prstGeom prst="rect">
             <a:avLst/>
           </a:prstGeom>
-          <a:noFill/>
         </p:spPr>
-        <p:txBody>
-          <a:bodyPr wrap="square" rtlCol="0">
-            <a:spAutoFit/>
-          </a:bodyPr>
-          <a:lstStyle/>
-          <a:p>
-            <a:r>
-              <a:rPr lang="sk-SK" sz="6000" noProof="0" dirty="0"/>
-              <a:t>Ukážka výsledného produktu</a:t>
-            </a:r>
-          </a:p>
-        </p:txBody>
-      </p:sp>
+      </p:pic>
     </p:spTree>
     <p:extLst>
       <p:ext uri="{BB962C8B-B14F-4D97-AF65-F5344CB8AC3E}">
-        <p14:creationId xmlns:p14="http://schemas.microsoft.com/office/powerpoint/2010/main" val="529435383"/>
+        <p14:creationId xmlns:p14="http://schemas.microsoft.com/office/powerpoint/2010/main" val="1061456676"/>
       </p:ext>
     </p:extLst>
   </p:cSld>
@@ -4009,6 +4097,71 @@
           <a:p>
             <a:r>
               <a:rPr lang="sk-SK" sz="6000" noProof="0" dirty="0"/>
+              <a:t>Ukážka výsledného produktu</a:t>
+            </a:r>
+          </a:p>
+        </p:txBody>
+      </p:sp>
+    </p:spTree>
+    <p:extLst>
+      <p:ext uri="{BB962C8B-B14F-4D97-AF65-F5344CB8AC3E}">
+        <p14:creationId xmlns:p14="http://schemas.microsoft.com/office/powerpoint/2010/main" val="529435383"/>
+      </p:ext>
+    </p:extLst>
+  </p:cSld>
+  <p:clrMapOvr>
+    <a:masterClrMapping/>
+  </p:clrMapOvr>
+</p:sld>
+</file>
+
+<file path=ppt/slides/slide16.xml><?xml version="1.0" encoding="utf-8"?>
+<p:sld xmlns:a="http://schemas.openxmlformats.org/drawingml/2006/main" xmlns:r="http://schemas.openxmlformats.org/officeDocument/2006/relationships" xmlns:p="http://schemas.openxmlformats.org/presentationml/2006/main">
+  <p:cSld>
+    <p:spTree>
+      <p:nvGrpSpPr>
+        <p:cNvPr id="1" name=""/>
+        <p:cNvGrpSpPr/>
+        <p:nvPr/>
+      </p:nvGrpSpPr>
+      <p:grpSpPr>
+        <a:xfrm>
+          <a:off x="0" y="0"/>
+          <a:ext cx="0" cy="0"/>
+          <a:chOff x="0" y="0"/>
+          <a:chExt cx="0" cy="0"/>
+        </a:xfrm>
+      </p:grpSpPr>
+      <p:sp>
+        <p:nvSpPr>
+          <p:cNvPr id="6" name="BlokTextu 5">
+            <a:extLst>
+              <a:ext uri="{FF2B5EF4-FFF2-40B4-BE49-F238E27FC236}">
+                <a16:creationId xmlns:a16="http://schemas.microsoft.com/office/drawing/2014/main" id="{08597A8F-7FB2-4750-B896-0FAD63F62091}"/>
+              </a:ext>
+            </a:extLst>
+          </p:cNvPr>
+          <p:cNvSpPr txBox="1"/>
+          <p:nvPr/>
+        </p:nvSpPr>
+        <p:spPr>
+          <a:xfrm>
+            <a:off x="639288" y="2921168"/>
+            <a:ext cx="10913423" cy="1015663"/>
+          </a:xfrm>
+          <a:prstGeom prst="rect">
+            <a:avLst/>
+          </a:prstGeom>
+          <a:noFill/>
+        </p:spPr>
+        <p:txBody>
+          <a:bodyPr wrap="square" rtlCol="0">
+            <a:spAutoFit/>
+          </a:bodyPr>
+          <a:lstStyle/>
+          <a:p>
+            <a:r>
+              <a:rPr lang="sk-SK" sz="6000" noProof="0" dirty="0"/>
               <a:t>Priestor na Vaše otázky</a:t>
             </a:r>
           </a:p>
@@ -4027,7 +4180,7 @@
 </p:sld>
 </file>
 
-<file path=ppt/slides/slide16.xml><?xml version="1.0" encoding="utf-8"?>
+<file path=ppt/slides/slide17.xml><?xml version="1.0" encoding="utf-8"?>
 <p:sld xmlns:a="http://schemas.openxmlformats.org/drawingml/2006/main" xmlns:r="http://schemas.openxmlformats.org/officeDocument/2006/relationships" xmlns:p="http://schemas.openxmlformats.org/presentationml/2006/main">
   <p:cSld>
     <p:spTree>
@@ -4398,14 +4551,14 @@
               <a:t>Karty sa ukladajú </a:t>
             </a:r>
             <a:br>
-              <a:rPr lang="en-GB" noProof="0" dirty="0"/>
+              <a:rPr lang="sk-SK" noProof="0" dirty="0"/>
             </a:br>
             <a:r>
               <a:rPr lang="sk-SK" noProof="0" dirty="0"/>
               <a:t>do pamäte ako</a:t>
             </a:r>
             <a:br>
-              <a:rPr lang="en-GB" dirty="0"/>
+              <a:rPr lang="sk-SK" noProof="0" dirty="0"/>
             </a:br>
             <a:r>
               <a:rPr lang="sk-SK" noProof="0" dirty="0" err="1"/>
@@ -4430,7 +4583,7 @@
               <a:t>LAN server je spustiteľný</a:t>
             </a:r>
             <a:br>
-              <a:rPr lang="en-GB" dirty="0"/>
+              <a:rPr lang="sk-SK" noProof="0" dirty="0"/>
             </a:br>
             <a:r>
               <a:rPr lang="sk-SK" noProof="0" dirty="0"/>
@@ -4888,11 +5041,7 @@
           <a:p>
             <a:r>
               <a:rPr lang="sk-SK" noProof="0" dirty="0"/>
-              <a:t>Nasadenie aplikácie na verejný </a:t>
-            </a:r>
-            <a:r>
-              <a:rPr lang="en-GB" noProof="0" dirty="0"/>
-              <a:t>Oracle </a:t>
+              <a:t>Nasadenie aplikácie na verejný Oracle </a:t>
             </a:r>
             <a:r>
               <a:rPr lang="sk-SK" noProof="0" dirty="0" err="1"/>

</xml_diff>